<commit_message>
docs(deck): embed deck images as data to remove local-path leak
pptxgenjs stored the source file path as image alt-text, leaking C:\Users\harsh\AppData\... (the Windows username) into the public .pptx on slides 6-7. Re-embed the screenshots as base64 data with explicit altText so no filesystem path is written.
</commit_message>
<xml_diff>
--- a/deck/SENTINEL_Submission.pptx
+++ b/deck/SENTINEL_Submission.pptx
@@ -4997,7 +4997,7 @@
       </p:sp>
       <p:pic>
         <p:nvPicPr>
-          <p:cNvPr id="12" name="Image 0" descr="C:\Users\harsh\AppData\Local\Temp\dash-shots\shot-live.png">    </p:cNvPr>
+          <p:cNvPr id="12" name="Image 0" descr="SENTINEL dashboard, attack blocked">    </p:cNvPr>
           <p:cNvPicPr>
             <a:picLocks noChangeAspect="1"/>
           </p:cNvPicPr>
@@ -5209,7 +5209,7 @@
       </p:sp>
       <p:pic>
         <p:nvPicPr>
-          <p:cNvPr id="4" name="Image 0" descr="C:\Users\harsh\AppData\Local\Temp\dash-shots\shot-outbox.png">    </p:cNvPr>
+          <p:cNvPr id="4" name="Image 0" descr="Outbox with vs without SENTINEL">    </p:cNvPr>
           <p:cNvPicPr>
             <a:picLocks noChangeAspect="1"/>
           </p:cNvPicPr>
@@ -5275,7 +5275,7 @@
       </p:sp>
       <p:pic>
         <p:nvPicPr>
-          <p:cNvPr id="6" name="Image 1" descr="C:\Users\harsh\AppData\Local\Temp\dash-shots\shot-killchain.png">    </p:cNvPr>
+          <p:cNvPr id="6" name="Image 1" descr="Forensic kill chain and Azure capability matrix">    </p:cNvPr>
           <p:cNvPicPr>
             <a:picLocks noChangeAspect="1"/>
           </p:cNvPicPr>

</xml_diff>